<commit_message>
Create PDF of models figure
</commit_message>
<xml_diff>
--- a/img/models/models.pptx
+++ b/img/models/models.pptx
@@ -254,7 +254,7 @@
           <a:p>
             <a:fld id="{19729664-E51F-9D43-AC1D-89266E3D84E7}" type="datetimeFigureOut">
               <a:rPr lang="en-US" smtClean="0"/>
-              <a:t>3/2/26</a:t>
+              <a:t>3/3/26</a:t>
             </a:fld>
             <a:endParaRPr lang="en-US"/>
           </a:p>
@@ -424,7 +424,7 @@
           <a:p>
             <a:fld id="{19729664-E51F-9D43-AC1D-89266E3D84E7}" type="datetimeFigureOut">
               <a:rPr lang="en-US" smtClean="0"/>
-              <a:t>3/2/26</a:t>
+              <a:t>3/3/26</a:t>
             </a:fld>
             <a:endParaRPr lang="en-US"/>
           </a:p>
@@ -604,7 +604,7 @@
           <a:p>
             <a:fld id="{19729664-E51F-9D43-AC1D-89266E3D84E7}" type="datetimeFigureOut">
               <a:rPr lang="en-US" smtClean="0"/>
-              <a:t>3/2/26</a:t>
+              <a:t>3/3/26</a:t>
             </a:fld>
             <a:endParaRPr lang="en-US"/>
           </a:p>
@@ -774,7 +774,7 @@
           <a:p>
             <a:fld id="{19729664-E51F-9D43-AC1D-89266E3D84E7}" type="datetimeFigureOut">
               <a:rPr lang="en-US" smtClean="0"/>
-              <a:t>3/2/26</a:t>
+              <a:t>3/3/26</a:t>
             </a:fld>
             <a:endParaRPr lang="en-US"/>
           </a:p>
@@ -1020,7 +1020,7 @@
           <a:p>
             <a:fld id="{19729664-E51F-9D43-AC1D-89266E3D84E7}" type="datetimeFigureOut">
               <a:rPr lang="en-US" smtClean="0"/>
-              <a:t>3/2/26</a:t>
+              <a:t>3/3/26</a:t>
             </a:fld>
             <a:endParaRPr lang="en-US"/>
           </a:p>
@@ -1252,7 +1252,7 @@
           <a:p>
             <a:fld id="{19729664-E51F-9D43-AC1D-89266E3D84E7}" type="datetimeFigureOut">
               <a:rPr lang="en-US" smtClean="0"/>
-              <a:t>3/2/26</a:t>
+              <a:t>3/3/26</a:t>
             </a:fld>
             <a:endParaRPr lang="en-US"/>
           </a:p>
@@ -1619,7 +1619,7 @@
           <a:p>
             <a:fld id="{19729664-E51F-9D43-AC1D-89266E3D84E7}" type="datetimeFigureOut">
               <a:rPr lang="en-US" smtClean="0"/>
-              <a:t>3/2/26</a:t>
+              <a:t>3/3/26</a:t>
             </a:fld>
             <a:endParaRPr lang="en-US"/>
           </a:p>
@@ -1737,7 +1737,7 @@
           <a:p>
             <a:fld id="{19729664-E51F-9D43-AC1D-89266E3D84E7}" type="datetimeFigureOut">
               <a:rPr lang="en-US" smtClean="0"/>
-              <a:t>3/2/26</a:t>
+              <a:t>3/3/26</a:t>
             </a:fld>
             <a:endParaRPr lang="en-US"/>
           </a:p>
@@ -1832,7 +1832,7 @@
           <a:p>
             <a:fld id="{19729664-E51F-9D43-AC1D-89266E3D84E7}" type="datetimeFigureOut">
               <a:rPr lang="en-US" smtClean="0"/>
-              <a:t>3/2/26</a:t>
+              <a:t>3/3/26</a:t>
             </a:fld>
             <a:endParaRPr lang="en-US"/>
           </a:p>
@@ -2109,7 +2109,7 @@
           <a:p>
             <a:fld id="{19729664-E51F-9D43-AC1D-89266E3D84E7}" type="datetimeFigureOut">
               <a:rPr lang="en-US" smtClean="0"/>
-              <a:t>3/2/26</a:t>
+              <a:t>3/3/26</a:t>
             </a:fld>
             <a:endParaRPr lang="en-US"/>
           </a:p>
@@ -2366,7 +2366,7 @@
           <a:p>
             <a:fld id="{19729664-E51F-9D43-AC1D-89266E3D84E7}" type="datetimeFigureOut">
               <a:rPr lang="en-US" smtClean="0"/>
-              <a:t>3/2/26</a:t>
+              <a:t>3/3/26</a:t>
             </a:fld>
             <a:endParaRPr lang="en-US"/>
           </a:p>
@@ -2579,7 +2579,7 @@
           <a:p>
             <a:fld id="{19729664-E51F-9D43-AC1D-89266E3D84E7}" type="datetimeFigureOut">
               <a:rPr lang="en-US" smtClean="0"/>
-              <a:t>3/2/26</a:t>
+              <a:t>3/3/26</a:t>
             </a:fld>
             <a:endParaRPr lang="en-US"/>
           </a:p>

</xml_diff>